<commit_message>
fix(etl): upgrade yfinance and fix plotly config warnings
</commit_message>
<xml_diff>
--- a/Elite_Pro_Dashboard_Presentation.pptx
+++ b/Elite_Pro_Dashboard_Presentation.pptx
@@ -11,7 +11,7 @@
     <p:sldId id="259" r:id="rId10"/>
     <p:sldId id="260" r:id="rId11"/>
   </p:sldIdLst>
-  <p:sldSz cx="12188952" cy="6858000" type="screen4x3"/>
+  <p:sldSz cx="9144000" cy="6858000" type="screen4x3"/>
   <p:notesSz cx="6858000" cy="9144000"/>
   <p:defaultTextStyle>
     <a:defPPr>
@@ -3085,14 +3085,6 @@
 <file path=ppt/slides/slide1.xml><?xml version="1.0" encoding="utf-8"?>
 <p:sld xmlns:a="http://schemas.openxmlformats.org/drawingml/2006/main" xmlns:p="http://schemas.openxmlformats.org/presentationml/2006/main" xmlns:r="http://schemas.openxmlformats.org/officeDocument/2006/relationships">
   <p:cSld>
-    <p:bg>
-      <p:bgPr>
-        <a:solidFill>
-          <a:srgbClr val="0A0A0A"/>
-        </a:solidFill>
-        <a:effectLst/>
-      </p:bgPr>
-    </p:bg>
     <p:spTree>
       <p:nvGrpSpPr>
         <p:cNvPr id="1" name=""/>
@@ -3102,179 +3094,47 @@
       <p:grpSpPr/>
       <p:sp>
         <p:nvSpPr>
-          <p:cNvPr id="2" name="Rectangle 1"/>
-          <p:cNvSpPr/>
-          <p:nvPr/>
-        </p:nvSpPr>
-        <p:spPr>
-          <a:xfrm>
-            <a:off x="0" y="3108960"/>
-            <a:ext cx="12188952" cy="91440"/>
-          </a:xfrm>
-          <a:prstGeom prst="rect">
-            <a:avLst/>
-          </a:prstGeom>
-          <a:solidFill>
-            <a:srgbClr val="00D4FF"/>
-          </a:solidFill>
-          <a:ln>
-            <a:noFill/>
-          </a:ln>
-        </p:spPr>
-        <p:style>
-          <a:lnRef idx="1">
-            <a:schemeClr val="accent1"/>
-          </a:lnRef>
-          <a:fillRef idx="3">
-            <a:schemeClr val="accent1"/>
-          </a:fillRef>
-          <a:effectRef idx="2">
-            <a:schemeClr val="accent1"/>
-          </a:effectRef>
-          <a:fontRef idx="minor">
-            <a:schemeClr val="lt1"/>
-          </a:fontRef>
-        </p:style>
-        <p:txBody>
-          <a:bodyPr rtlCol="0" anchor="ctr"/>
-          <a:lstStyle/>
-          <a:p>
-            <a:pPr algn="ctr"/>
-          </a:p>
-        </p:txBody>
-      </p:sp>
-      <p:sp>
-        <p:nvSpPr>
-          <p:cNvPr id="3" name="TextBox 2"/>
-          <p:cNvSpPr txBox="1"/>
-          <p:nvPr/>
-        </p:nvSpPr>
-        <p:spPr>
-          <a:xfrm>
-            <a:off x="5577840" y="1097280"/>
-            <a:ext cx="914400" cy="914400"/>
-          </a:xfrm>
-          <a:prstGeom prst="rect">
-            <a:avLst/>
-          </a:prstGeom>
-          <a:noFill/>
-        </p:spPr>
-        <p:txBody>
-          <a:bodyPr wrap="none">
-            <a:spAutoFit/>
-          </a:bodyPr>
-          <a:lstStyle/>
-          <a:p>
-            <a:pPr algn="ctr"/>
-            <a:r>
-              <a:rPr sz="6000" b="0">
-                <a:solidFill>
-                  <a:srgbClr val="FFFFFF"/>
-                </a:solidFill>
-              </a:rPr>
-              <a:t>🚀</a:t>
-            </a:r>
-          </a:p>
-        </p:txBody>
-      </p:sp>
-      <p:sp>
-        <p:nvSpPr>
-          <p:cNvPr id="4" name="TextBox 3"/>
-          <p:cNvSpPr txBox="1"/>
-          <p:nvPr/>
-        </p:nvSpPr>
-        <p:spPr>
-          <a:xfrm>
-            <a:off x="1097280" y="2011680"/>
-            <a:ext cx="10058400" cy="914400"/>
-          </a:xfrm>
-          <a:prstGeom prst="rect">
-            <a:avLst/>
-          </a:prstGeom>
-          <a:noFill/>
-        </p:spPr>
-        <p:txBody>
-          <a:bodyPr wrap="none">
-            <a:spAutoFit/>
-          </a:bodyPr>
-          <a:lstStyle/>
-          <a:p>
-            <a:pPr algn="ctr"/>
-            <a:r>
-              <a:rPr sz="4400" b="1">
-                <a:solidFill>
-                  <a:srgbClr val="FFFFFF"/>
-                </a:solidFill>
-              </a:rPr>
-              <a:t>Elite Pro Stock Analytics</a:t>
-            </a:r>
-          </a:p>
-        </p:txBody>
-      </p:sp>
-      <p:sp>
-        <p:nvSpPr>
-          <p:cNvPr id="5" name="TextBox 4"/>
-          <p:cNvSpPr txBox="1"/>
-          <p:nvPr/>
-        </p:nvSpPr>
-        <p:spPr>
-          <a:xfrm>
-            <a:off x="1097280" y="3474720"/>
-            <a:ext cx="10058400" cy="457200"/>
-          </a:xfrm>
-          <a:prstGeom prst="rect">
-            <a:avLst/>
-          </a:prstGeom>
-          <a:noFill/>
-        </p:spPr>
-        <p:txBody>
-          <a:bodyPr wrap="none">
-            <a:spAutoFit/>
-          </a:bodyPr>
-          <a:lstStyle/>
-          <a:p>
-            <a:pPr algn="ctr"/>
-            <a:r>
-              <a:rPr sz="2200" b="0">
-                <a:solidFill>
-                  <a:srgbClr val="00D4FF"/>
-                </a:solidFill>
-              </a:rPr>
-              <a:t>End-to-End Modern Data Stack for Financial Markets</a:t>
-            </a:r>
-          </a:p>
-        </p:txBody>
-      </p:sp>
-      <p:sp>
-        <p:nvSpPr>
-          <p:cNvPr id="6" name="TextBox 5"/>
-          <p:cNvSpPr txBox="1"/>
-          <p:nvPr/>
-        </p:nvSpPr>
-        <p:spPr>
-          <a:xfrm>
-            <a:off x="1097280" y="4114800"/>
-            <a:ext cx="10058400" cy="457200"/>
-          </a:xfrm>
-          <a:prstGeom prst="rect">
-            <a:avLst/>
-          </a:prstGeom>
-          <a:noFill/>
-        </p:spPr>
-        <p:txBody>
-          <a:bodyPr wrap="none">
-            <a:spAutoFit/>
-          </a:bodyPr>
-          <a:lstStyle/>
-          <a:p>
-            <a:pPr algn="ctr"/>
-            <a:r>
-              <a:rPr sz="1600" b="0">
-                <a:solidFill>
-                  <a:srgbClr val="B0B0B0"/>
-                </a:solidFill>
-              </a:rPr>
-              <a:t>Python · DuckDB · Airflow · Streamlit · GitHub Actions</a:t>
+          <p:cNvPr id="2" name="Title 1"/>
+          <p:cNvSpPr>
+            <a:spLocks noGrp="1"/>
+          </p:cNvSpPr>
+          <p:nvPr>
+            <p:ph type="ctrTitle"/>
+          </p:nvPr>
+        </p:nvSpPr>
+        <p:spPr/>
+        <p:txBody>
+          <a:bodyPr/>
+          <a:lstStyle/>
+          <a:p>
+            <a:r>
+              <a:t>Elite Pro: Stock ETL &amp; AI Analytics Dashboard</a:t>
+            </a:r>
+          </a:p>
+        </p:txBody>
+      </p:sp>
+      <p:sp>
+        <p:nvSpPr>
+          <p:cNvPr id="3" name="Subtitle 2"/>
+          <p:cNvSpPr>
+            <a:spLocks noGrp="1"/>
+          </p:cNvSpPr>
+          <p:nvPr>
+            <p:ph type="subTitle" idx="1"/>
+          </p:nvPr>
+        </p:nvSpPr>
+        <p:spPr/>
+        <p:txBody>
+          <a:bodyPr/>
+          <a:lstStyle/>
+          <a:p>
+            <a:r>
+              <a:t>Project Pitch &amp; Technical Deep-Dive</a:t>
+            </a:r>
+          </a:p>
+          <a:p>
+            <a:r>
+              <a:t>Generated by Antigravity AI</a:t>
             </a:r>
           </a:p>
         </p:txBody>
@@ -3290,14 +3150,6 @@
 <file path=ppt/slides/slide2.xml><?xml version="1.0" encoding="utf-8"?>
 <p:sld xmlns:a="http://schemas.openxmlformats.org/drawingml/2006/main" xmlns:p="http://schemas.openxmlformats.org/presentationml/2006/main" xmlns:r="http://schemas.openxmlformats.org/officeDocument/2006/relationships">
   <p:cSld>
-    <p:bg>
-      <p:bgPr>
-        <a:solidFill>
-          <a:srgbClr val="0A0A0A"/>
-        </a:solidFill>
-        <a:effectLst/>
-      </p:bgPr>
-    </p:bg>
     <p:spTree>
       <p:nvGrpSpPr>
         <p:cNvPr id="1" name=""/>
@@ -3307,442 +3159,60 @@
       <p:grpSpPr/>
       <p:sp>
         <p:nvSpPr>
-          <p:cNvPr id="2" name="TextBox 1"/>
-          <p:cNvSpPr txBox="1"/>
-          <p:nvPr/>
-        </p:nvSpPr>
-        <p:spPr>
-          <a:xfrm>
-            <a:off x="457200" y="274320"/>
-            <a:ext cx="9144000" cy="731520"/>
-          </a:xfrm>
-          <a:prstGeom prst="rect">
-            <a:avLst/>
-          </a:prstGeom>
-          <a:noFill/>
-        </p:spPr>
-        <p:txBody>
-          <a:bodyPr wrap="none">
-            <a:spAutoFit/>
-          </a:bodyPr>
-          <a:lstStyle/>
-          <a:p>
-            <a:pPr algn="l"/>
-            <a:r>
-              <a:rPr sz="3200" b="1">
-                <a:solidFill>
-                  <a:srgbClr val="00D4FF"/>
-                </a:solidFill>
-              </a:rPr>
-              <a:t>🎯 Project Overview</a:t>
-            </a:r>
-          </a:p>
-        </p:txBody>
-      </p:sp>
-      <p:sp>
-        <p:nvSpPr>
-          <p:cNvPr id="3" name="TextBox 2"/>
-          <p:cNvSpPr txBox="1"/>
-          <p:nvPr/>
-        </p:nvSpPr>
-        <p:spPr>
-          <a:xfrm>
-            <a:off x="548640" y="1371600"/>
-            <a:ext cx="2743200" cy="365760"/>
-          </a:xfrm>
-          <a:prstGeom prst="rect">
-            <a:avLst/>
-          </a:prstGeom>
-          <a:noFill/>
-        </p:spPr>
-        <p:txBody>
-          <a:bodyPr wrap="none">
-            <a:spAutoFit/>
-          </a:bodyPr>
-          <a:lstStyle/>
-          <a:p>
-            <a:pPr algn="l"/>
-            <a:r>
-              <a:rPr sz="1800" b="1">
-                <a:solidFill>
-                  <a:srgbClr val="00FF88"/>
-                </a:solidFill>
-              </a:rPr>
-              <a:t>● 💎 Universe:</a:t>
-            </a:r>
-          </a:p>
-        </p:txBody>
-      </p:sp>
-      <p:sp>
-        <p:nvSpPr>
-          <p:cNvPr id="4" name="TextBox 3"/>
-          <p:cNvSpPr txBox="1"/>
-          <p:nvPr/>
-        </p:nvSpPr>
-        <p:spPr>
-          <a:xfrm>
-            <a:off x="3200400" y="1371600"/>
-            <a:ext cx="8229600" cy="365760"/>
-          </a:xfrm>
-          <a:prstGeom prst="rect">
-            <a:avLst/>
-          </a:prstGeom>
-          <a:noFill/>
-        </p:spPr>
-        <p:txBody>
-          <a:bodyPr wrap="none">
-            <a:spAutoFit/>
-          </a:bodyPr>
-          <a:lstStyle/>
-          <a:p>
-            <a:pPr algn="l"/>
-            <a:r>
-              <a:rPr sz="1800" b="0">
-                <a:solidFill>
-                  <a:srgbClr val="FFFFFF"/>
-                </a:solidFill>
-              </a:rPr>
-              <a:t>Tracking 20 global Tech/Healthcare giants (US, EU, CN).</a:t>
-            </a:r>
-          </a:p>
-        </p:txBody>
-      </p:sp>
-      <p:sp>
-        <p:nvSpPr>
-          <p:cNvPr id="5" name="TextBox 4"/>
-          <p:cNvSpPr txBox="1"/>
-          <p:nvPr/>
-        </p:nvSpPr>
-        <p:spPr>
-          <a:xfrm>
-            <a:off x="548640" y="2240280"/>
-            <a:ext cx="2743200" cy="365760"/>
-          </a:xfrm>
-          <a:prstGeom prst="rect">
-            <a:avLst/>
-          </a:prstGeom>
-          <a:noFill/>
-        </p:spPr>
-        <p:txBody>
-          <a:bodyPr wrap="none">
-            <a:spAutoFit/>
-          </a:bodyPr>
-          <a:lstStyle/>
-          <a:p>
-            <a:pPr algn="l"/>
-            <a:r>
-              <a:rPr sz="1800" b="1">
-                <a:solidFill>
-                  <a:srgbClr val="00FF88"/>
-                </a:solidFill>
-              </a:rPr>
-              <a:t>● 📊 Fundamental:</a:t>
-            </a:r>
-          </a:p>
-        </p:txBody>
-      </p:sp>
-      <p:sp>
-        <p:nvSpPr>
-          <p:cNvPr id="6" name="TextBox 5"/>
-          <p:cNvSpPr txBox="1"/>
-          <p:nvPr/>
-        </p:nvSpPr>
-        <p:spPr>
-          <a:xfrm>
-            <a:off x="3200400" y="2240280"/>
-            <a:ext cx="8229600" cy="365760"/>
-          </a:xfrm>
-          <a:prstGeom prst="rect">
-            <a:avLst/>
-          </a:prstGeom>
-          <a:noFill/>
-        </p:spPr>
-        <p:txBody>
-          <a:bodyPr wrap="none">
-            <a:spAutoFit/>
-          </a:bodyPr>
-          <a:lstStyle/>
-          <a:p>
-            <a:pPr algn="l"/>
-            <a:r>
-              <a:rPr sz="1800" b="0">
-                <a:solidFill>
-                  <a:srgbClr val="FFFFFF"/>
-                </a:solidFill>
-              </a:rPr>
-              <a:t>4-Year Revenue &amp; EPS History with YoY growth analysis.</a:t>
-            </a:r>
-          </a:p>
-        </p:txBody>
-      </p:sp>
-      <p:sp>
-        <p:nvSpPr>
-          <p:cNvPr id="7" name="TextBox 6"/>
-          <p:cNvSpPr txBox="1"/>
-          <p:nvPr/>
-        </p:nvSpPr>
-        <p:spPr>
-          <a:xfrm>
-            <a:off x="548640" y="3108960"/>
-            <a:ext cx="2743200" cy="365760"/>
-          </a:xfrm>
-          <a:prstGeom prst="rect">
-            <a:avLst/>
-          </a:prstGeom>
-          <a:noFill/>
-        </p:spPr>
-        <p:txBody>
-          <a:bodyPr wrap="none">
-            <a:spAutoFit/>
-          </a:bodyPr>
-          <a:lstStyle/>
-          <a:p>
-            <a:pPr algn="l"/>
-            <a:r>
-              <a:rPr sz="1800" b="1">
-                <a:solidFill>
-                  <a:srgbClr val="00FF88"/>
-                </a:solidFill>
-              </a:rPr>
-              <a:t>● 🧠 AI Engine:</a:t>
-            </a:r>
-          </a:p>
-        </p:txBody>
-      </p:sp>
-      <p:sp>
-        <p:nvSpPr>
-          <p:cNvPr id="8" name="TextBox 7"/>
-          <p:cNvSpPr txBox="1"/>
-          <p:nvPr/>
-        </p:nvSpPr>
-        <p:spPr>
-          <a:xfrm>
-            <a:off x="3200400" y="3108960"/>
-            <a:ext cx="8229600" cy="365760"/>
-          </a:xfrm>
-          <a:prstGeom prst="rect">
-            <a:avLst/>
-          </a:prstGeom>
-          <a:noFill/>
-        </p:spPr>
-        <p:txBody>
-          <a:bodyPr wrap="none">
-            <a:spAutoFit/>
-          </a:bodyPr>
-          <a:lstStyle/>
-          <a:p>
-            <a:pPr algn="l"/>
-            <a:r>
-              <a:rPr sz="1800" b="0">
-                <a:solidFill>
-                  <a:srgbClr val="FFFFFF"/>
-                </a:solidFill>
-              </a:rPr>
-              <a:t>Unified 9-factor scoring model (Valuation, Growth, Techs).</a:t>
-            </a:r>
-          </a:p>
-        </p:txBody>
-      </p:sp>
-      <p:sp>
-        <p:nvSpPr>
-          <p:cNvPr id="9" name="TextBox 8"/>
-          <p:cNvSpPr txBox="1"/>
-          <p:nvPr/>
-        </p:nvSpPr>
-        <p:spPr>
-          <a:xfrm>
-            <a:off x="548640" y="3977639"/>
-            <a:ext cx="2743200" cy="365760"/>
-          </a:xfrm>
-          <a:prstGeom prst="rect">
-            <a:avLst/>
-          </a:prstGeom>
-          <a:noFill/>
-        </p:spPr>
-        <p:txBody>
-          <a:bodyPr wrap="none">
-            <a:spAutoFit/>
-          </a:bodyPr>
-          <a:lstStyle/>
-          <a:p>
-            <a:pPr algn="l"/>
-            <a:r>
-              <a:rPr sz="1800" b="1">
-                <a:solidFill>
-                  <a:srgbClr val="00FF88"/>
-                </a:solidFill>
-              </a:rPr>
-              <a:t>● 🏦 Warehouse:</a:t>
-            </a:r>
-          </a:p>
-        </p:txBody>
-      </p:sp>
-      <p:sp>
-        <p:nvSpPr>
-          <p:cNvPr id="10" name="TextBox 9"/>
-          <p:cNvSpPr txBox="1"/>
-          <p:nvPr/>
-        </p:nvSpPr>
-        <p:spPr>
-          <a:xfrm>
-            <a:off x="3200400" y="3977639"/>
-            <a:ext cx="8229600" cy="365760"/>
-          </a:xfrm>
-          <a:prstGeom prst="rect">
-            <a:avLst/>
-          </a:prstGeom>
-          <a:noFill/>
-        </p:spPr>
-        <p:txBody>
-          <a:bodyPr wrap="none">
-            <a:spAutoFit/>
-          </a:bodyPr>
-          <a:lstStyle/>
-          <a:p>
-            <a:pPr algn="l"/>
-            <a:r>
-              <a:rPr sz="1800" b="0">
-                <a:solidFill>
-                  <a:srgbClr val="FFFFFF"/>
-                </a:solidFill>
-              </a:rPr>
-              <a:t>Medallion Architecture (Bronze/Silver/Gold) on DuckDB.</a:t>
-            </a:r>
-          </a:p>
-        </p:txBody>
-      </p:sp>
-      <p:sp>
-        <p:nvSpPr>
-          <p:cNvPr id="11" name="TextBox 10"/>
-          <p:cNvSpPr txBox="1"/>
-          <p:nvPr/>
-        </p:nvSpPr>
-        <p:spPr>
-          <a:xfrm>
-            <a:off x="548640" y="4846320"/>
-            <a:ext cx="2743200" cy="365760"/>
-          </a:xfrm>
-          <a:prstGeom prst="rect">
-            <a:avLst/>
-          </a:prstGeom>
-          <a:noFill/>
-        </p:spPr>
-        <p:txBody>
-          <a:bodyPr wrap="none">
-            <a:spAutoFit/>
-          </a:bodyPr>
-          <a:lstStyle/>
-          <a:p>
-            <a:pPr algn="l"/>
-            <a:r>
-              <a:rPr sz="1800" b="1">
-                <a:solidFill>
-                  <a:srgbClr val="00FF88"/>
-                </a:solidFill>
-              </a:rPr>
-              <a:t>● ⏲️ Automation:</a:t>
-            </a:r>
-          </a:p>
-        </p:txBody>
-      </p:sp>
-      <p:sp>
-        <p:nvSpPr>
-          <p:cNvPr id="12" name="TextBox 11"/>
-          <p:cNvSpPr txBox="1"/>
-          <p:nvPr/>
-        </p:nvSpPr>
-        <p:spPr>
-          <a:xfrm>
-            <a:off x="3200400" y="4846320"/>
-            <a:ext cx="8229600" cy="365760"/>
-          </a:xfrm>
-          <a:prstGeom prst="rect">
-            <a:avLst/>
-          </a:prstGeom>
-          <a:noFill/>
-        </p:spPr>
-        <p:txBody>
-          <a:bodyPr wrap="none">
-            <a:spAutoFit/>
-          </a:bodyPr>
-          <a:lstStyle/>
-          <a:p>
-            <a:pPr algn="l"/>
-            <a:r>
-              <a:rPr sz="1800" b="0">
-                <a:solidFill>
-                  <a:srgbClr val="FFFFFF"/>
-                </a:solidFill>
-              </a:rPr>
-              <a:t>Fully automated daily updates via Airflow &amp; GitHub Actions.</a:t>
-            </a:r>
-          </a:p>
-        </p:txBody>
-      </p:sp>
-      <p:sp>
-        <p:nvSpPr>
-          <p:cNvPr id="13" name="TextBox 12"/>
-          <p:cNvSpPr txBox="1"/>
-          <p:nvPr/>
-        </p:nvSpPr>
-        <p:spPr>
-          <a:xfrm>
-            <a:off x="548640" y="5715000"/>
-            <a:ext cx="2743200" cy="365760"/>
-          </a:xfrm>
-          <a:prstGeom prst="rect">
-            <a:avLst/>
-          </a:prstGeom>
-          <a:noFill/>
-        </p:spPr>
-        <p:txBody>
-          <a:bodyPr wrap="none">
-            <a:spAutoFit/>
-          </a:bodyPr>
-          <a:lstStyle/>
-          <a:p>
-            <a:pPr algn="l"/>
-            <a:r>
-              <a:rPr sz="1800" b="1">
-                <a:solidFill>
-                  <a:srgbClr val="00FF88"/>
-                </a:solidFill>
-              </a:rPr>
-              <a:t>● 📈 Reporting:</a:t>
-            </a:r>
-          </a:p>
-        </p:txBody>
-      </p:sp>
-      <p:sp>
-        <p:nvSpPr>
-          <p:cNvPr id="14" name="TextBox 13"/>
-          <p:cNvSpPr txBox="1"/>
-          <p:nvPr/>
-        </p:nvSpPr>
-        <p:spPr>
-          <a:xfrm>
-            <a:off x="3200400" y="5715000"/>
-            <a:ext cx="8229600" cy="365760"/>
-          </a:xfrm>
-          <a:prstGeom prst="rect">
-            <a:avLst/>
-          </a:prstGeom>
-          <a:noFill/>
-        </p:spPr>
-        <p:txBody>
-          <a:bodyPr wrap="none">
-            <a:spAutoFit/>
-          </a:bodyPr>
-          <a:lstStyle/>
-          <a:p>
-            <a:pPr algn="l"/>
-            <a:r>
-              <a:rPr sz="1800" b="0">
-                <a:solidFill>
-                  <a:srgbClr val="FFFFFF"/>
-                </a:solidFill>
-              </a:rPr>
-              <a:t>Rich HTML Email reports &amp; Interactive Streamlit Dashboard.</a:t>
+          <p:cNvPr id="2" name="Title 1"/>
+          <p:cNvSpPr>
+            <a:spLocks noGrp="1"/>
+          </p:cNvSpPr>
+          <p:nvPr>
+            <p:ph type="title"/>
+          </p:nvPr>
+        </p:nvSpPr>
+        <p:spPr/>
+        <p:txBody>
+          <a:bodyPr/>
+          <a:lstStyle/>
+          <a:p>
+            <a:r>
+              <a:t>Data Architecture &amp; ETL Engine</a:t>
+            </a:r>
+          </a:p>
+        </p:txBody>
+      </p:sp>
+      <p:sp>
+        <p:nvSpPr>
+          <p:cNvPr id="3" name="Content Placeholder 2"/>
+          <p:cNvSpPr>
+            <a:spLocks noGrp="1"/>
+          </p:cNvSpPr>
+          <p:nvPr>
+            <p:ph idx="1"/>
+          </p:nvPr>
+        </p:nvSpPr>
+        <p:spPr/>
+        <p:txBody>
+          <a:bodyPr/>
+          <a:lstStyle/>
+          <a:p>
+            <a:r>
+              <a:t>• Apache Airflow: Automated data orchestration and update cycles.</a:t>
+            </a:r>
+          </a:p>
+          <a:p>
+            <a:pPr/>
+            <a:r>
+              <a:t>• DuckDB: High-performance analytical warehouse for market data.</a:t>
+            </a:r>
+          </a:p>
+          <a:p>
+            <a:pPr/>
+            <a:r>
+              <a:t>• Star-Schema: Optimized Data Marts for tickers, prices, and financials.</a:t>
+            </a:r>
+          </a:p>
+          <a:p>
+            <a:pPr/>
+            <a:r>
+              <a:t>• Scalability: Handling large-scale datasets with efficient I/O.</a:t>
             </a:r>
           </a:p>
         </p:txBody>
@@ -3758,14 +3228,6 @@
 <file path=ppt/slides/slide3.xml><?xml version="1.0" encoding="utf-8"?>
 <p:sld xmlns:a="http://schemas.openxmlformats.org/drawingml/2006/main" xmlns:p="http://schemas.openxmlformats.org/presentationml/2006/main" xmlns:r="http://schemas.openxmlformats.org/officeDocument/2006/relationships">
   <p:cSld>
-    <p:bg>
-      <p:bgPr>
-        <a:solidFill>
-          <a:srgbClr val="0A0A0A"/>
-        </a:solidFill>
-        <a:effectLst/>
-      </p:bgPr>
-    </p:bg>
     <p:spTree>
       <p:nvGrpSpPr>
         <p:cNvPr id="1" name=""/>
@@ -3775,589 +3237,60 @@
       <p:grpSpPr/>
       <p:sp>
         <p:nvSpPr>
-          <p:cNvPr id="2" name="TextBox 1"/>
-          <p:cNvSpPr txBox="1"/>
-          <p:nvPr/>
-        </p:nvSpPr>
-        <p:spPr>
-          <a:xfrm>
-            <a:off x="457200" y="274320"/>
-            <a:ext cx="9144000" cy="731520"/>
-          </a:xfrm>
-          <a:prstGeom prst="rect">
-            <a:avLst/>
-          </a:prstGeom>
-          <a:noFill/>
-        </p:spPr>
-        <p:txBody>
-          <a:bodyPr wrap="none">
-            <a:spAutoFit/>
-          </a:bodyPr>
-          <a:lstStyle/>
-          <a:p>
-            <a:pPr algn="l"/>
-            <a:r>
-              <a:rPr sz="3200" b="1">
-                <a:solidFill>
-                  <a:srgbClr val="00D4FF"/>
-                </a:solidFill>
-              </a:rPr>
-              <a:t>🏗️ Technical Stack (The 'Pro' Layer)</a:t>
-            </a:r>
-          </a:p>
-        </p:txBody>
-      </p:sp>
-      <p:sp>
-        <p:nvSpPr>
-          <p:cNvPr id="3" name="Rectangle 2"/>
-          <p:cNvSpPr/>
-          <p:nvPr/>
-        </p:nvSpPr>
-        <p:spPr>
-          <a:xfrm>
-            <a:off x="457200" y="1645920"/>
-            <a:ext cx="11247120" cy="731520"/>
-          </a:xfrm>
-          <a:prstGeom prst="rect">
-            <a:avLst/>
-          </a:prstGeom>
-          <a:solidFill>
-            <a:srgbClr val="1E1E1E"/>
-          </a:solidFill>
-          <a:ln>
-            <a:noFill/>
-          </a:ln>
-        </p:spPr>
-        <p:style>
-          <a:lnRef idx="1">
-            <a:schemeClr val="accent1"/>
-          </a:lnRef>
-          <a:fillRef idx="3">
-            <a:schemeClr val="accent1"/>
-          </a:fillRef>
-          <a:effectRef idx="2">
-            <a:schemeClr val="accent1"/>
-          </a:effectRef>
-          <a:fontRef idx="minor">
-            <a:schemeClr val="lt1"/>
-          </a:fontRef>
-        </p:style>
-        <p:txBody>
-          <a:bodyPr rtlCol="0" anchor="ctr"/>
-          <a:lstStyle/>
-          <a:p>
-            <a:pPr algn="ctr"/>
-          </a:p>
-        </p:txBody>
-      </p:sp>
-      <p:sp>
-        <p:nvSpPr>
-          <p:cNvPr id="4" name="TextBox 3"/>
-          <p:cNvSpPr txBox="1"/>
-          <p:nvPr/>
-        </p:nvSpPr>
-        <p:spPr>
-          <a:xfrm>
-            <a:off x="640080" y="1783080"/>
-            <a:ext cx="3200400" cy="457200"/>
-          </a:xfrm>
-          <a:prstGeom prst="rect">
-            <a:avLst/>
-          </a:prstGeom>
-          <a:noFill/>
-        </p:spPr>
-        <p:txBody>
-          <a:bodyPr wrap="none">
-            <a:spAutoFit/>
-          </a:bodyPr>
-          <a:lstStyle/>
-          <a:p>
-            <a:pPr algn="l"/>
-            <a:r>
-              <a:rPr sz="1800" b="1">
-                <a:solidFill>
-                  <a:srgbClr val="00FF88"/>
-                </a:solidFill>
-              </a:rPr>
-              <a:t>Python/yfinance</a:t>
-            </a:r>
-          </a:p>
-        </p:txBody>
-      </p:sp>
-      <p:sp>
-        <p:nvSpPr>
-          <p:cNvPr id="5" name="TextBox 4"/>
-          <p:cNvSpPr txBox="1"/>
-          <p:nvPr/>
-        </p:nvSpPr>
-        <p:spPr>
-          <a:xfrm>
-            <a:off x="4114800" y="1783080"/>
-            <a:ext cx="7315200" cy="457200"/>
-          </a:xfrm>
-          <a:prstGeom prst="rect">
-            <a:avLst/>
-          </a:prstGeom>
-          <a:noFill/>
-        </p:spPr>
-        <p:txBody>
-          <a:bodyPr wrap="none">
-            <a:spAutoFit/>
-          </a:bodyPr>
-          <a:lstStyle/>
-          <a:p>
-            <a:pPr algn="l"/>
-            <a:r>
-              <a:rPr sz="1600" b="0">
-                <a:solidFill>
-                  <a:srgbClr val="FFFFFF"/>
-                </a:solidFill>
-              </a:rPr>
-              <a:t>Robust data extraction with automatic NaN filtering.</a:t>
-            </a:r>
-          </a:p>
-        </p:txBody>
-      </p:sp>
-      <p:sp>
-        <p:nvSpPr>
-          <p:cNvPr id="6" name="Rectangle 5"/>
-          <p:cNvSpPr/>
-          <p:nvPr/>
-        </p:nvSpPr>
-        <p:spPr>
-          <a:xfrm>
-            <a:off x="457200" y="2560320"/>
-            <a:ext cx="11247120" cy="731520"/>
-          </a:xfrm>
-          <a:prstGeom prst="rect">
-            <a:avLst/>
-          </a:prstGeom>
-          <a:solidFill>
-            <a:srgbClr val="1E1E1E"/>
-          </a:solidFill>
-          <a:ln>
-            <a:noFill/>
-          </a:ln>
-        </p:spPr>
-        <p:style>
-          <a:lnRef idx="1">
-            <a:schemeClr val="accent1"/>
-          </a:lnRef>
-          <a:fillRef idx="3">
-            <a:schemeClr val="accent1"/>
-          </a:fillRef>
-          <a:effectRef idx="2">
-            <a:schemeClr val="accent1"/>
-          </a:effectRef>
-          <a:fontRef idx="minor">
-            <a:schemeClr val="lt1"/>
-          </a:fontRef>
-        </p:style>
-        <p:txBody>
-          <a:bodyPr rtlCol="0" anchor="ctr"/>
-          <a:lstStyle/>
-          <a:p>
-            <a:pPr algn="ctr"/>
-          </a:p>
-        </p:txBody>
-      </p:sp>
-      <p:sp>
-        <p:nvSpPr>
-          <p:cNvPr id="7" name="TextBox 6"/>
-          <p:cNvSpPr txBox="1"/>
-          <p:nvPr/>
-        </p:nvSpPr>
-        <p:spPr>
-          <a:xfrm>
-            <a:off x="640080" y="2697479"/>
-            <a:ext cx="3200400" cy="457200"/>
-          </a:xfrm>
-          <a:prstGeom prst="rect">
-            <a:avLst/>
-          </a:prstGeom>
-          <a:noFill/>
-        </p:spPr>
-        <p:txBody>
-          <a:bodyPr wrap="none">
-            <a:spAutoFit/>
-          </a:bodyPr>
-          <a:lstStyle/>
-          <a:p>
-            <a:pPr algn="l"/>
-            <a:r>
-              <a:rPr sz="1800" b="1">
-                <a:solidFill>
-                  <a:srgbClr val="00FF88"/>
-                </a:solidFill>
-              </a:rPr>
-              <a:t>DuckDB</a:t>
-            </a:r>
-          </a:p>
-        </p:txBody>
-      </p:sp>
-      <p:sp>
-        <p:nvSpPr>
-          <p:cNvPr id="8" name="TextBox 7"/>
-          <p:cNvSpPr txBox="1"/>
-          <p:nvPr/>
-        </p:nvSpPr>
-        <p:spPr>
-          <a:xfrm>
-            <a:off x="4114800" y="2697479"/>
-            <a:ext cx="7315200" cy="457200"/>
-          </a:xfrm>
-          <a:prstGeom prst="rect">
-            <a:avLst/>
-          </a:prstGeom>
-          <a:noFill/>
-        </p:spPr>
-        <p:txBody>
-          <a:bodyPr wrap="none">
-            <a:spAutoFit/>
-          </a:bodyPr>
-          <a:lstStyle/>
-          <a:p>
-            <a:pPr algn="l"/>
-            <a:r>
-              <a:rPr sz="1600" b="0">
-                <a:solidFill>
-                  <a:srgbClr val="FFFFFF"/>
-                </a:solidFill>
-              </a:rPr>
-              <a:t>High-performance analytics engine (Columnar storage).</a:t>
-            </a:r>
-          </a:p>
-        </p:txBody>
-      </p:sp>
-      <p:sp>
-        <p:nvSpPr>
-          <p:cNvPr id="9" name="Rectangle 8"/>
-          <p:cNvSpPr/>
-          <p:nvPr/>
-        </p:nvSpPr>
-        <p:spPr>
-          <a:xfrm>
-            <a:off x="457200" y="3474720"/>
-            <a:ext cx="11247120" cy="731520"/>
-          </a:xfrm>
-          <a:prstGeom prst="rect">
-            <a:avLst/>
-          </a:prstGeom>
-          <a:solidFill>
-            <a:srgbClr val="1E1E1E"/>
-          </a:solidFill>
-          <a:ln>
-            <a:noFill/>
-          </a:ln>
-        </p:spPr>
-        <p:style>
-          <a:lnRef idx="1">
-            <a:schemeClr val="accent1"/>
-          </a:lnRef>
-          <a:fillRef idx="3">
-            <a:schemeClr val="accent1"/>
-          </a:fillRef>
-          <a:effectRef idx="2">
-            <a:schemeClr val="accent1"/>
-          </a:effectRef>
-          <a:fontRef idx="minor">
-            <a:schemeClr val="lt1"/>
-          </a:fontRef>
-        </p:style>
-        <p:txBody>
-          <a:bodyPr rtlCol="0" anchor="ctr"/>
-          <a:lstStyle/>
-          <a:p>
-            <a:pPr algn="ctr"/>
-          </a:p>
-        </p:txBody>
-      </p:sp>
-      <p:sp>
-        <p:nvSpPr>
-          <p:cNvPr id="10" name="TextBox 9"/>
-          <p:cNvSpPr txBox="1"/>
-          <p:nvPr/>
-        </p:nvSpPr>
-        <p:spPr>
-          <a:xfrm>
-            <a:off x="640080" y="3611879"/>
-            <a:ext cx="3200400" cy="457200"/>
-          </a:xfrm>
-          <a:prstGeom prst="rect">
-            <a:avLst/>
-          </a:prstGeom>
-          <a:noFill/>
-        </p:spPr>
-        <p:txBody>
-          <a:bodyPr wrap="none">
-            <a:spAutoFit/>
-          </a:bodyPr>
-          <a:lstStyle/>
-          <a:p>
-            <a:pPr algn="l"/>
-            <a:r>
-              <a:rPr sz="1800" b="1">
-                <a:solidFill>
-                  <a:srgbClr val="00FF88"/>
-                </a:solidFill>
-              </a:rPr>
-              <a:t>Airflow/Docker</a:t>
-            </a:r>
-          </a:p>
-        </p:txBody>
-      </p:sp>
-      <p:sp>
-        <p:nvSpPr>
-          <p:cNvPr id="11" name="TextBox 10"/>
-          <p:cNvSpPr txBox="1"/>
-          <p:nvPr/>
-        </p:nvSpPr>
-        <p:spPr>
-          <a:xfrm>
-            <a:off x="4114800" y="3611879"/>
-            <a:ext cx="7315200" cy="457200"/>
-          </a:xfrm>
-          <a:prstGeom prst="rect">
-            <a:avLst/>
-          </a:prstGeom>
-          <a:noFill/>
-        </p:spPr>
-        <p:txBody>
-          <a:bodyPr wrap="none">
-            <a:spAutoFit/>
-          </a:bodyPr>
-          <a:lstStyle/>
-          <a:p>
-            <a:pPr algn="l"/>
-            <a:r>
-              <a:rPr sz="1600" b="0">
-                <a:solidFill>
-                  <a:srgbClr val="FFFFFF"/>
-                </a:solidFill>
-              </a:rPr>
-              <a:t>Orchestration &amp; reproducibility in any environment.</a:t>
-            </a:r>
-          </a:p>
-        </p:txBody>
-      </p:sp>
-      <p:sp>
-        <p:nvSpPr>
-          <p:cNvPr id="12" name="Rectangle 11"/>
-          <p:cNvSpPr/>
-          <p:nvPr/>
-        </p:nvSpPr>
-        <p:spPr>
-          <a:xfrm>
-            <a:off x="457200" y="4389120"/>
-            <a:ext cx="11247120" cy="731520"/>
-          </a:xfrm>
-          <a:prstGeom prst="rect">
-            <a:avLst/>
-          </a:prstGeom>
-          <a:solidFill>
-            <a:srgbClr val="1E1E1E"/>
-          </a:solidFill>
-          <a:ln>
-            <a:noFill/>
-          </a:ln>
-        </p:spPr>
-        <p:style>
-          <a:lnRef idx="1">
-            <a:schemeClr val="accent1"/>
-          </a:lnRef>
-          <a:fillRef idx="3">
-            <a:schemeClr val="accent1"/>
-          </a:fillRef>
-          <a:effectRef idx="2">
-            <a:schemeClr val="accent1"/>
-          </a:effectRef>
-          <a:fontRef idx="minor">
-            <a:schemeClr val="lt1"/>
-          </a:fontRef>
-        </p:style>
-        <p:txBody>
-          <a:bodyPr rtlCol="0" anchor="ctr"/>
-          <a:lstStyle/>
-          <a:p>
-            <a:pPr algn="ctr"/>
-          </a:p>
-        </p:txBody>
-      </p:sp>
-      <p:sp>
-        <p:nvSpPr>
-          <p:cNvPr id="13" name="TextBox 12"/>
-          <p:cNvSpPr txBox="1"/>
-          <p:nvPr/>
-        </p:nvSpPr>
-        <p:spPr>
-          <a:xfrm>
-            <a:off x="640080" y="4526280"/>
-            <a:ext cx="3200400" cy="457200"/>
-          </a:xfrm>
-          <a:prstGeom prst="rect">
-            <a:avLst/>
-          </a:prstGeom>
-          <a:noFill/>
-        </p:spPr>
-        <p:txBody>
-          <a:bodyPr wrap="none">
-            <a:spAutoFit/>
-          </a:bodyPr>
-          <a:lstStyle/>
-          <a:p>
-            <a:pPr algn="l"/>
-            <a:r>
-              <a:rPr sz="1800" b="1">
-                <a:solidFill>
-                  <a:srgbClr val="00FF88"/>
-                </a:solidFill>
-              </a:rPr>
-              <a:t>Streamlit</a:t>
-            </a:r>
-          </a:p>
-        </p:txBody>
-      </p:sp>
-      <p:sp>
-        <p:nvSpPr>
-          <p:cNvPr id="14" name="TextBox 13"/>
-          <p:cNvSpPr txBox="1"/>
-          <p:nvPr/>
-        </p:nvSpPr>
-        <p:spPr>
-          <a:xfrm>
-            <a:off x="4114800" y="4526280"/>
-            <a:ext cx="7315200" cy="457200"/>
-          </a:xfrm>
-          <a:prstGeom prst="rect">
-            <a:avLst/>
-          </a:prstGeom>
-          <a:noFill/>
-        </p:spPr>
-        <p:txBody>
-          <a:bodyPr wrap="none">
-            <a:spAutoFit/>
-          </a:bodyPr>
-          <a:lstStyle/>
-          <a:p>
-            <a:pPr algn="l"/>
-            <a:r>
-              <a:rPr sz="1600" b="0">
-                <a:solidFill>
-                  <a:srgbClr val="FFFFFF"/>
-                </a:solidFill>
-              </a:rPr>
-              <a:t>Premium Glassmorphism UI for real-time visualization.</a:t>
-            </a:r>
-          </a:p>
-        </p:txBody>
-      </p:sp>
-      <p:sp>
-        <p:nvSpPr>
-          <p:cNvPr id="15" name="Rectangle 14"/>
-          <p:cNvSpPr/>
-          <p:nvPr/>
-        </p:nvSpPr>
-        <p:spPr>
-          <a:xfrm>
-            <a:off x="457200" y="5303520"/>
-            <a:ext cx="11247120" cy="731520"/>
-          </a:xfrm>
-          <a:prstGeom prst="rect">
-            <a:avLst/>
-          </a:prstGeom>
-          <a:solidFill>
-            <a:srgbClr val="1E1E1E"/>
-          </a:solidFill>
-          <a:ln>
-            <a:noFill/>
-          </a:ln>
-        </p:spPr>
-        <p:style>
-          <a:lnRef idx="1">
-            <a:schemeClr val="accent1"/>
-          </a:lnRef>
-          <a:fillRef idx="3">
-            <a:schemeClr val="accent1"/>
-          </a:fillRef>
-          <a:effectRef idx="2">
-            <a:schemeClr val="accent1"/>
-          </a:effectRef>
-          <a:fontRef idx="minor">
-            <a:schemeClr val="lt1"/>
-          </a:fontRef>
-        </p:style>
-        <p:txBody>
-          <a:bodyPr rtlCol="0" anchor="ctr"/>
-          <a:lstStyle/>
-          <a:p>
-            <a:pPr algn="ctr"/>
-          </a:p>
-        </p:txBody>
-      </p:sp>
-      <p:sp>
-        <p:nvSpPr>
-          <p:cNvPr id="16" name="TextBox 15"/>
-          <p:cNvSpPr txBox="1"/>
-          <p:nvPr/>
-        </p:nvSpPr>
-        <p:spPr>
-          <a:xfrm>
-            <a:off x="640080" y="5440680"/>
-            <a:ext cx="3200400" cy="457200"/>
-          </a:xfrm>
-          <a:prstGeom prst="rect">
-            <a:avLst/>
-          </a:prstGeom>
-          <a:noFill/>
-        </p:spPr>
-        <p:txBody>
-          <a:bodyPr wrap="none">
-            <a:spAutoFit/>
-          </a:bodyPr>
-          <a:lstStyle/>
-          <a:p>
-            <a:pPr algn="l"/>
-            <a:r>
-              <a:rPr sz="1800" b="1">
-                <a:solidFill>
-                  <a:srgbClr val="00FF88"/>
-                </a:solidFill>
-              </a:rPr>
-              <a:t>GitHub Actions</a:t>
-            </a:r>
-          </a:p>
-        </p:txBody>
-      </p:sp>
-      <p:sp>
-        <p:nvSpPr>
-          <p:cNvPr id="17" name="TextBox 16"/>
-          <p:cNvSpPr txBox="1"/>
-          <p:nvPr/>
-        </p:nvSpPr>
-        <p:spPr>
-          <a:xfrm>
-            <a:off x="4114800" y="5440680"/>
-            <a:ext cx="7315200" cy="457200"/>
-          </a:xfrm>
-          <a:prstGeom prst="rect">
-            <a:avLst/>
-          </a:prstGeom>
-          <a:noFill/>
-        </p:spPr>
-        <p:txBody>
-          <a:bodyPr wrap="none">
-            <a:spAutoFit/>
-          </a:bodyPr>
-          <a:lstStyle/>
-          <a:p>
-            <a:pPr algn="l"/>
-            <a:r>
-              <a:rPr sz="1600" b="0">
-                <a:solidFill>
-                  <a:srgbClr val="FFFFFF"/>
-                </a:solidFill>
-              </a:rPr>
-              <a:t>24/7 Serverless automation and CI/CD sync.</a:t>
+          <p:cNvPr id="2" name="Title 1"/>
+          <p:cNvSpPr>
+            <a:spLocks noGrp="1"/>
+          </p:cNvSpPr>
+          <p:nvPr>
+            <p:ph type="title"/>
+          </p:nvPr>
+        </p:nvSpPr>
+        <p:spPr/>
+        <p:txBody>
+          <a:bodyPr/>
+          <a:lstStyle/>
+          <a:p>
+            <a:r>
+              <a:t>6-Pillar Proprietary AI Scoring</a:t>
+            </a:r>
+          </a:p>
+        </p:txBody>
+      </p:sp>
+      <p:sp>
+        <p:nvSpPr>
+          <p:cNvPr id="3" name="Content Placeholder 2"/>
+          <p:cNvSpPr>
+            <a:spLocks noGrp="1"/>
+          </p:cNvSpPr>
+          <p:nvPr>
+            <p:ph idx="1"/>
+          </p:nvPr>
+        </p:nvSpPr>
+        <p:spPr/>
+        <p:txBody>
+          <a:bodyPr/>
+          <a:lstStyle/>
+          <a:p>
+            <a:r>
+              <a:t>• Multi-Factor Model: Valuation, Profitability, Financial Health.</a:t>
+            </a:r>
+          </a:p>
+          <a:p>
+            <a:pPr/>
+            <a:r>
+              <a:t>• Advanced Pillars: Shareholder Yield, Momentum, Analyst Estimates.</a:t>
+            </a:r>
+          </a:p>
+          <a:p>
+            <a:pPr/>
+            <a:r>
+              <a:t>• Sector-Aware Weighting: Dynamic scoring based on industry types.</a:t>
+            </a:r>
+          </a:p>
+          <a:p>
+            <a:pPr/>
+            <a:r>
+              <a:t>• Quant-Native Logic: Combining fundamentals with technical signals.</a:t>
             </a:r>
           </a:p>
         </p:txBody>
@@ -4373,14 +3306,6 @@
 <file path=ppt/slides/slide4.xml><?xml version="1.0" encoding="utf-8"?>
 <p:sld xmlns:a="http://schemas.openxmlformats.org/drawingml/2006/main" xmlns:p="http://schemas.openxmlformats.org/presentationml/2006/main" xmlns:r="http://schemas.openxmlformats.org/officeDocument/2006/relationships">
   <p:cSld>
-    <p:bg>
-      <p:bgPr>
-        <a:solidFill>
-          <a:srgbClr val="0A0A0A"/>
-        </a:solidFill>
-        <a:effectLst/>
-      </p:bgPr>
-    </p:bg>
     <p:spTree>
       <p:nvGrpSpPr>
         <p:cNvPr id="1" name=""/>
@@ -4390,478 +3315,60 @@
       <p:grpSpPr/>
       <p:sp>
         <p:nvSpPr>
-          <p:cNvPr id="2" name="TextBox 1"/>
-          <p:cNvSpPr txBox="1"/>
-          <p:nvPr/>
-        </p:nvSpPr>
-        <p:spPr>
-          <a:xfrm>
-            <a:off x="457200" y="274320"/>
-            <a:ext cx="9144000" cy="731520"/>
-          </a:xfrm>
-          <a:prstGeom prst="rect">
-            <a:avLst/>
-          </a:prstGeom>
-          <a:noFill/>
-        </p:spPr>
-        <p:txBody>
-          <a:bodyPr wrap="none">
-            <a:spAutoFit/>
-          </a:bodyPr>
-          <a:lstStyle/>
-          <a:p>
-            <a:pPr algn="l"/>
-            <a:r>
-              <a:rPr sz="3200" b="1">
-                <a:solidFill>
-                  <a:srgbClr val="FFCC00"/>
-                </a:solidFill>
-              </a:rPr>
-              <a:t>📊 Current Market Insights (Live Data)</a:t>
-            </a:r>
-          </a:p>
-        </p:txBody>
-      </p:sp>
-      <p:sp>
-        <p:nvSpPr>
-          <p:cNvPr id="3" name="Rectangle 2"/>
-          <p:cNvSpPr/>
-          <p:nvPr/>
-        </p:nvSpPr>
-        <p:spPr>
-          <a:xfrm>
-            <a:off x="914400" y="1645920"/>
-            <a:ext cx="10058400" cy="1005840"/>
-          </a:xfrm>
-          <a:prstGeom prst="rect">
-            <a:avLst/>
-          </a:prstGeom>
-          <a:solidFill>
-            <a:srgbClr val="1E1E1E"/>
-          </a:solidFill>
-          <a:ln>
-            <a:noFill/>
-          </a:ln>
-        </p:spPr>
-        <p:style>
-          <a:lnRef idx="1">
-            <a:schemeClr val="accent1"/>
-          </a:lnRef>
-          <a:fillRef idx="3">
-            <a:schemeClr val="accent1"/>
-          </a:fillRef>
-          <a:effectRef idx="2">
-            <a:schemeClr val="accent1"/>
-          </a:effectRef>
-          <a:fontRef idx="minor">
-            <a:schemeClr val="lt1"/>
-          </a:fontRef>
-        </p:style>
-        <p:txBody>
-          <a:bodyPr rtlCol="0" anchor="ctr"/>
-          <a:lstStyle/>
-          <a:p>
-            <a:pPr algn="ctr"/>
-          </a:p>
-        </p:txBody>
-      </p:sp>
-      <p:sp>
-        <p:nvSpPr>
-          <p:cNvPr id="4" name="TextBox 3"/>
-          <p:cNvSpPr txBox="1"/>
-          <p:nvPr/>
-        </p:nvSpPr>
-        <p:spPr>
-          <a:xfrm>
-            <a:off x="1097280" y="1783080"/>
-            <a:ext cx="3657600" cy="457200"/>
-          </a:xfrm>
-          <a:prstGeom prst="rect">
-            <a:avLst/>
-          </a:prstGeom>
-          <a:noFill/>
-        </p:spPr>
-        <p:txBody>
-          <a:bodyPr wrap="none">
-            <a:spAutoFit/>
-          </a:bodyPr>
-          <a:lstStyle/>
-          <a:p>
-            <a:pPr algn="l"/>
-            <a:r>
-              <a:rPr sz="2200" b="1">
-                <a:solidFill>
-                  <a:srgbClr val="00FF88"/>
-                </a:solidFill>
-              </a:rPr>
-              <a:t>🏆 Top Performer</a:t>
-            </a:r>
-          </a:p>
-        </p:txBody>
-      </p:sp>
-      <p:sp>
-        <p:nvSpPr>
-          <p:cNvPr id="5" name="TextBox 4"/>
-          <p:cNvSpPr txBox="1"/>
-          <p:nvPr/>
-        </p:nvSpPr>
-        <p:spPr>
-          <a:xfrm>
-            <a:off x="1097280" y="2194560"/>
-            <a:ext cx="9144000" cy="457200"/>
-          </a:xfrm>
-          <a:prstGeom prst="rect">
-            <a:avLst/>
-          </a:prstGeom>
-          <a:noFill/>
-        </p:spPr>
-        <p:txBody>
-          <a:bodyPr wrap="none">
-            <a:spAutoFit/>
-          </a:bodyPr>
-          <a:lstStyle/>
-          <a:p>
-            <a:pPr algn="l"/>
-            <a:r>
-              <a:rPr sz="1800" b="0">
-                <a:solidFill>
-                  <a:srgbClr val="FFFFFF"/>
-                </a:solidFill>
-              </a:rPr>
-              <a:t>DELL (+1.82% avg daily)</a:t>
-            </a:r>
-          </a:p>
-        </p:txBody>
-      </p:sp>
-      <p:sp>
-        <p:nvSpPr>
-          <p:cNvPr id="6" name="Rectangle 5"/>
-          <p:cNvSpPr/>
-          <p:nvPr/>
-        </p:nvSpPr>
-        <p:spPr>
-          <a:xfrm>
-            <a:off x="914400" y="2834640"/>
-            <a:ext cx="10058400" cy="1005840"/>
-          </a:xfrm>
-          <a:prstGeom prst="rect">
-            <a:avLst/>
-          </a:prstGeom>
-          <a:solidFill>
-            <a:srgbClr val="1E1E1E"/>
-          </a:solidFill>
-          <a:ln>
-            <a:noFill/>
-          </a:ln>
-        </p:spPr>
-        <p:style>
-          <a:lnRef idx="1">
-            <a:schemeClr val="accent1"/>
-          </a:lnRef>
-          <a:fillRef idx="3">
-            <a:schemeClr val="accent1"/>
-          </a:fillRef>
-          <a:effectRef idx="2">
-            <a:schemeClr val="accent1"/>
-          </a:effectRef>
-          <a:fontRef idx="minor">
-            <a:schemeClr val="lt1"/>
-          </a:fontRef>
-        </p:style>
-        <p:txBody>
-          <a:bodyPr rtlCol="0" anchor="ctr"/>
-          <a:lstStyle/>
-          <a:p>
-            <a:pPr algn="ctr"/>
-          </a:p>
-        </p:txBody>
-      </p:sp>
-      <p:sp>
-        <p:nvSpPr>
-          <p:cNvPr id="7" name="TextBox 6"/>
-          <p:cNvSpPr txBox="1"/>
-          <p:nvPr/>
-        </p:nvSpPr>
-        <p:spPr>
-          <a:xfrm>
-            <a:off x="1097280" y="2971800"/>
-            <a:ext cx="3657600" cy="457200"/>
-          </a:xfrm>
-          <a:prstGeom prst="rect">
-            <a:avLst/>
-          </a:prstGeom>
-          <a:noFill/>
-        </p:spPr>
-        <p:txBody>
-          <a:bodyPr wrap="none">
-            <a:spAutoFit/>
-          </a:bodyPr>
-          <a:lstStyle/>
-          <a:p>
-            <a:pPr algn="l"/>
-            <a:r>
-              <a:rPr sz="2200" b="1">
-                <a:solidFill>
-                  <a:srgbClr val="00FF88"/>
-                </a:solidFill>
-              </a:rPr>
-              <a:t>📡 Trend Guard</a:t>
-            </a:r>
-          </a:p>
-        </p:txBody>
-      </p:sp>
-      <p:sp>
-        <p:nvSpPr>
-          <p:cNvPr id="8" name="TextBox 7"/>
-          <p:cNvSpPr txBox="1"/>
-          <p:nvPr/>
-        </p:nvSpPr>
-        <p:spPr>
-          <a:xfrm>
-            <a:off x="1097280" y="3383280"/>
-            <a:ext cx="9144000" cy="457200"/>
-          </a:xfrm>
-          <a:prstGeom prst="rect">
-            <a:avLst/>
-          </a:prstGeom>
-          <a:noFill/>
-        </p:spPr>
-        <p:txBody>
-          <a:bodyPr wrap="none">
-            <a:spAutoFit/>
-          </a:bodyPr>
-          <a:lstStyle/>
-          <a:p>
-            <a:pPr algn="l"/>
-            <a:r>
-              <a:rPr sz="1800" b="0">
-                <a:solidFill>
-                  <a:srgbClr val="FFFFFF"/>
-                </a:solidFill>
-              </a:rPr>
-              <a:t>2/19 stocks in Bullish trend (MA20 &gt; MA50).</a:t>
-            </a:r>
-          </a:p>
-        </p:txBody>
-      </p:sp>
-      <p:sp>
-        <p:nvSpPr>
-          <p:cNvPr id="9" name="Rectangle 8"/>
-          <p:cNvSpPr/>
-          <p:nvPr/>
-        </p:nvSpPr>
-        <p:spPr>
-          <a:xfrm>
-            <a:off x="914400" y="4023360"/>
-            <a:ext cx="10058400" cy="1005840"/>
-          </a:xfrm>
-          <a:prstGeom prst="rect">
-            <a:avLst/>
-          </a:prstGeom>
-          <a:solidFill>
-            <a:srgbClr val="1E1E1E"/>
-          </a:solidFill>
-          <a:ln>
-            <a:noFill/>
-          </a:ln>
-        </p:spPr>
-        <p:style>
-          <a:lnRef idx="1">
-            <a:schemeClr val="accent1"/>
-          </a:lnRef>
-          <a:fillRef idx="3">
-            <a:schemeClr val="accent1"/>
-          </a:fillRef>
-          <a:effectRef idx="2">
-            <a:schemeClr val="accent1"/>
-          </a:effectRef>
-          <a:fontRef idx="minor">
-            <a:schemeClr val="lt1"/>
-          </a:fontRef>
-        </p:style>
-        <p:txBody>
-          <a:bodyPr rtlCol="0" anchor="ctr"/>
-          <a:lstStyle/>
-          <a:p>
-            <a:pPr algn="ctr"/>
-          </a:p>
-        </p:txBody>
-      </p:sp>
-      <p:sp>
-        <p:nvSpPr>
-          <p:cNvPr id="10" name="TextBox 9"/>
-          <p:cNvSpPr txBox="1"/>
-          <p:nvPr/>
-        </p:nvSpPr>
-        <p:spPr>
-          <a:xfrm>
-            <a:off x="1097280" y="4160520"/>
-            <a:ext cx="3657600" cy="457200"/>
-          </a:xfrm>
-          <a:prstGeom prst="rect">
-            <a:avLst/>
-          </a:prstGeom>
-          <a:noFill/>
-        </p:spPr>
-        <p:txBody>
-          <a:bodyPr wrap="none">
-            <a:spAutoFit/>
-          </a:bodyPr>
-          <a:lstStyle/>
-          <a:p>
-            <a:pPr algn="l"/>
-            <a:r>
-              <a:rPr sz="2200" b="1">
-                <a:solidFill>
-                  <a:srgbClr val="00FF88"/>
-                </a:solidFill>
-              </a:rPr>
-              <a:t>📏 High Ground</a:t>
-            </a:r>
-          </a:p>
-        </p:txBody>
-      </p:sp>
-      <p:sp>
-        <p:nvSpPr>
-          <p:cNvPr id="11" name="TextBox 10"/>
-          <p:cNvSpPr txBox="1"/>
-          <p:nvPr/>
-        </p:nvSpPr>
-        <p:spPr>
-          <a:xfrm>
-            <a:off x="1097280" y="4572000"/>
-            <a:ext cx="9144000" cy="457200"/>
-          </a:xfrm>
-          <a:prstGeom prst="rect">
-            <a:avLst/>
-          </a:prstGeom>
-          <a:noFill/>
-        </p:spPr>
-        <p:txBody>
-          <a:bodyPr wrap="none">
-            <a:spAutoFit/>
-          </a:bodyPr>
-          <a:lstStyle/>
-          <a:p>
-            <a:pPr algn="l"/>
-            <a:r>
-              <a:rPr sz="1800" b="0">
-                <a:solidFill>
-                  <a:srgbClr val="FFFFFF"/>
-                </a:solidFill>
-              </a:rPr>
-              <a:t>DELL is closest to 52w high.</a:t>
-            </a:r>
-          </a:p>
-        </p:txBody>
-      </p:sp>
-      <p:sp>
-        <p:nvSpPr>
-          <p:cNvPr id="12" name="Rectangle 11"/>
-          <p:cNvSpPr/>
-          <p:nvPr/>
-        </p:nvSpPr>
-        <p:spPr>
-          <a:xfrm>
-            <a:off x="914400" y="5212080"/>
-            <a:ext cx="10058400" cy="1005840"/>
-          </a:xfrm>
-          <a:prstGeom prst="rect">
-            <a:avLst/>
-          </a:prstGeom>
-          <a:solidFill>
-            <a:srgbClr val="1E1E1E"/>
-          </a:solidFill>
-          <a:ln>
-            <a:noFill/>
-          </a:ln>
-        </p:spPr>
-        <p:style>
-          <a:lnRef idx="1">
-            <a:schemeClr val="accent1"/>
-          </a:lnRef>
-          <a:fillRef idx="3">
-            <a:schemeClr val="accent1"/>
-          </a:fillRef>
-          <a:effectRef idx="2">
-            <a:schemeClr val="accent1"/>
-          </a:effectRef>
-          <a:fontRef idx="minor">
-            <a:schemeClr val="lt1"/>
-          </a:fontRef>
-        </p:style>
-        <p:txBody>
-          <a:bodyPr rtlCol="0" anchor="ctr"/>
-          <a:lstStyle/>
-          <a:p>
-            <a:pPr algn="ctr"/>
-          </a:p>
-        </p:txBody>
-      </p:sp>
-      <p:sp>
-        <p:nvSpPr>
-          <p:cNvPr id="13" name="TextBox 12"/>
-          <p:cNvSpPr txBox="1"/>
-          <p:nvPr/>
-        </p:nvSpPr>
-        <p:spPr>
-          <a:xfrm>
-            <a:off x="1097280" y="5349240"/>
-            <a:ext cx="3657600" cy="457200"/>
-          </a:xfrm>
-          <a:prstGeom prst="rect">
-            <a:avLst/>
-          </a:prstGeom>
-          <a:noFill/>
-        </p:spPr>
-        <p:txBody>
-          <a:bodyPr wrap="none">
-            <a:spAutoFit/>
-          </a:bodyPr>
-          <a:lstStyle/>
-          <a:p>
-            <a:pPr algn="l"/>
-            <a:r>
-              <a:rPr sz="2200" b="1">
-                <a:solidFill>
-                  <a:srgbClr val="00FF88"/>
-                </a:solidFill>
-              </a:rPr>
-              <a:t>🛡️ Deep Value</a:t>
-            </a:r>
-          </a:p>
-        </p:txBody>
-      </p:sp>
-      <p:sp>
-        <p:nvSpPr>
-          <p:cNvPr id="14" name="TextBox 13"/>
-          <p:cNvSpPr txBox="1"/>
-          <p:nvPr/>
-        </p:nvSpPr>
-        <p:spPr>
-          <a:xfrm>
-            <a:off x="1097280" y="5760720"/>
-            <a:ext cx="9144000" cy="457200"/>
-          </a:xfrm>
-          <a:prstGeom prst="rect">
-            <a:avLst/>
-          </a:prstGeom>
-          <a:noFill/>
-        </p:spPr>
-        <p:txBody>
-          <a:bodyPr wrap="none">
-            <a:spAutoFit/>
-          </a:bodyPr>
-          <a:lstStyle/>
-          <a:p>
-            <a:pPr algn="l"/>
-            <a:r>
-              <a:rPr sz="1800" b="0">
-                <a:solidFill>
-                  <a:srgbClr val="FFFFFF"/>
-                </a:solidFill>
-              </a:rPr>
-              <a:t>Only 10 stocks corrected &gt;20%.</a:t>
+          <p:cNvPr id="2" name="Title 1"/>
+          <p:cNvSpPr>
+            <a:spLocks noGrp="1"/>
+          </p:cNvSpPr>
+          <p:nvPr>
+            <p:ph type="title"/>
+          </p:nvPr>
+        </p:nvSpPr>
+        <p:spPr/>
+        <p:txBody>
+          <a:bodyPr/>
+          <a:lstStyle/>
+          <a:p>
+            <a:r>
+              <a:t>News Analysis &amp; NLP Sentiment</a:t>
+            </a:r>
+          </a:p>
+        </p:txBody>
+      </p:sp>
+      <p:sp>
+        <p:nvSpPr>
+          <p:cNvPr id="3" name="Content Placeholder 2"/>
+          <p:cNvSpPr>
+            <a:spLocks noGrp="1"/>
+          </p:cNvSpPr>
+          <p:nvPr>
+            <p:ph idx="1"/>
+          </p:nvPr>
+        </p:nvSpPr>
+        <p:spPr/>
+        <p:txBody>
+          <a:bodyPr/>
+          <a:lstStyle/>
+          <a:p>
+            <a:r>
+              <a:t>• Hybrid NLP Framework: Utilizing TextBlob and FinBERT models.</a:t>
+            </a:r>
+          </a:p>
+          <a:p>
+            <a:pPr/>
+            <a:r>
+              <a:t>• Sentiment Integration: Real-time news analysis impact on AI Score.</a:t>
+            </a:r>
+          </a:p>
+          <a:p>
+            <a:pPr/>
+            <a:r>
+              <a:t>• Contextual Awareness: Sentiment as a catalyst for technical trends.</a:t>
+            </a:r>
+          </a:p>
+          <a:p>
+            <a:pPr/>
+            <a:r>
+              <a:t>• Automated Intelligence: Turning narrative noise into numeric alpha.</a:t>
             </a:r>
           </a:p>
         </p:txBody>
@@ -4877,14 +3384,6 @@
 <file path=ppt/slides/slide5.xml><?xml version="1.0" encoding="utf-8"?>
 <p:sld xmlns:a="http://schemas.openxmlformats.org/drawingml/2006/main" xmlns:p="http://schemas.openxmlformats.org/presentationml/2006/main" xmlns:r="http://schemas.openxmlformats.org/officeDocument/2006/relationships">
   <p:cSld>
-    <p:bg>
-      <p:bgPr>
-        <a:solidFill>
-          <a:srgbClr val="0A0A0A"/>
-        </a:solidFill>
-        <a:effectLst/>
-      </p:bgPr>
-    </p:bg>
     <p:spTree>
       <p:nvGrpSpPr>
         <p:cNvPr id="1" name=""/>
@@ -4894,102 +3393,60 @@
       <p:grpSpPr/>
       <p:sp>
         <p:nvSpPr>
-          <p:cNvPr id="2" name="TextBox 1"/>
-          <p:cNvSpPr txBox="1"/>
-          <p:nvPr/>
-        </p:nvSpPr>
-        <p:spPr>
-          <a:xfrm>
-            <a:off x="1097280" y="2286000"/>
-            <a:ext cx="10058400" cy="914400"/>
-          </a:xfrm>
-          <a:prstGeom prst="rect">
-            <a:avLst/>
-          </a:prstGeom>
-          <a:noFill/>
-        </p:spPr>
-        <p:txBody>
-          <a:bodyPr wrap="none">
-            <a:spAutoFit/>
-          </a:bodyPr>
-          <a:lstStyle/>
-          <a:p>
-            <a:pPr algn="ctr"/>
-            <a:r>
-              <a:rPr sz="4400" b="1">
-                <a:solidFill>
-                  <a:srgbClr val="FFFFFF"/>
-                </a:solidFill>
-              </a:rPr>
-              <a:t>Thank You! / Cảm ơn bạn!</a:t>
-            </a:r>
-          </a:p>
-        </p:txBody>
-      </p:sp>
-      <p:sp>
-        <p:nvSpPr>
-          <p:cNvPr id="3" name="TextBox 2"/>
-          <p:cNvSpPr txBox="1"/>
-          <p:nvPr/>
-        </p:nvSpPr>
-        <p:spPr>
-          <a:xfrm>
-            <a:off x="1097280" y="3657600"/>
-            <a:ext cx="10058400" cy="457200"/>
-          </a:xfrm>
-          <a:prstGeom prst="rect">
-            <a:avLst/>
-          </a:prstGeom>
-          <a:noFill/>
-        </p:spPr>
-        <p:txBody>
-          <a:bodyPr wrap="none">
-            <a:spAutoFit/>
-          </a:bodyPr>
-          <a:lstStyle/>
-          <a:p>
-            <a:pPr algn="ctr"/>
-            <a:r>
-              <a:rPr sz="1800" b="0">
-                <a:solidFill>
-                  <a:srgbClr val="00D4FF"/>
-                </a:solidFill>
-              </a:rPr>
-              <a:t>GitHub: github.com/luongdo94/stock_etl_pipeline_pro</a:t>
-            </a:r>
-          </a:p>
-        </p:txBody>
-      </p:sp>
-      <p:sp>
-        <p:nvSpPr>
-          <p:cNvPr id="4" name="TextBox 3"/>
-          <p:cNvSpPr txBox="1"/>
-          <p:nvPr/>
-        </p:nvSpPr>
-        <p:spPr>
-          <a:xfrm>
-            <a:off x="1097280" y="4572000"/>
-            <a:ext cx="10058400" cy="457200"/>
-          </a:xfrm>
-          <a:prstGeom prst="rect">
-            <a:avLst/>
-          </a:prstGeom>
-          <a:noFill/>
-        </p:spPr>
-        <p:txBody>
-          <a:bodyPr wrap="none">
-            <a:spAutoFit/>
-          </a:bodyPr>
-          <a:lstStyle/>
-          <a:p>
-            <a:pPr algn="ctr"/>
-            <a:r>
-              <a:rPr sz="1600" b="0">
-                <a:solidFill>
-                  <a:srgbClr val="B0B0B0"/>
-                </a:solidFill>
-              </a:rPr>
-              <a:t>Questions &amp; Discussion</a:t>
+          <p:cNvPr id="2" name="Title 1"/>
+          <p:cNvSpPr>
+            <a:spLocks noGrp="1"/>
+          </p:cNvSpPr>
+          <p:nvPr>
+            <p:ph type="title"/>
+          </p:nvPr>
+        </p:nvSpPr>
+        <p:spPr/>
+        <p:txBody>
+          <a:bodyPr/>
+          <a:lstStyle/>
+          <a:p>
+            <a:r>
+              <a:t>Premium Experience &amp; Roadmap</a:t>
+            </a:r>
+          </a:p>
+        </p:txBody>
+      </p:sp>
+      <p:sp>
+        <p:nvSpPr>
+          <p:cNvPr id="3" name="Content Placeholder 2"/>
+          <p:cNvSpPr>
+            <a:spLocks noGrp="1"/>
+          </p:cNvSpPr>
+          <p:nvPr>
+            <p:ph idx="1"/>
+          </p:nvPr>
+        </p:nvSpPr>
+        <p:spPr/>
+        <p:txBody>
+          <a:bodyPr/>
+          <a:lstStyle/>
+          <a:p>
+            <a:r>
+              <a:t>• Elite UI/UX: Dark-mode high-density Dashboard in Streamlit.</a:t>
+            </a:r>
+          </a:p>
+          <a:p>
+            <a:pPr/>
+            <a:r>
+              <a:t>• Predictive Analytics: Monte Carlo simulations and popover breakdowns.</a:t>
+            </a:r>
+          </a:p>
+          <a:p>
+            <a:pPr/>
+            <a:r>
+              <a:t>• 2026 Roadmap: Portfolio tracking, Real-time alerts, Deep Learning integration.</a:t>
+            </a:r>
+          </a:p>
+          <a:p>
+            <a:pPr/>
+            <a:r>
+              <a:t>• Expansion: Global market scaling and SaaS deployment.</a:t>
             </a:r>
           </a:p>
         </p:txBody>

</xml_diff>